<commit_message>
Add closing slide for today's FeverGate pitch status.
Include Groups A-D, live app, and four-audience feedback form on the final slide.

Co-authored-by: Cursor <cursoragent@cursor.com>
</commit_message>
<xml_diff>
--- a/FeverGate-5min-Pitch.pptx
+++ b/FeverGate-5min-Pitch.pptx
@@ -14,6 +14,7 @@
     <p:sldId id="262" r:id="rId14"/>
     <p:sldId id="263" r:id="rId15"/>
     <p:sldId id="264" r:id="rId16"/>
+    <p:sldId id="265" r:id="rId17"/>
   </p:sldIdLst>
   <p:sldSz cx="9144000" cy="6858000" type="screen4x3"/>
   <p:notesSz cx="6858000" cy="9144000"/>
@@ -860,7 +861,7 @@
           <a:lstStyle/>
           <a:p>
             <a:r>
-              <a:t>Built for real clinic friction — stock unpredictability, epidemiology reporting, and a separate supervisor view so medics stay focused.</a:t>
+              <a:t>Built for real clinic friction — stock unpredictability, epidemiology reporting, and a separate supervisor view so medics stay focused. Today we also ship structured feedback forms for four audiences.</a:t>
             </a:r>
           </a:p>
         </p:txBody>
@@ -1000,7 +1001,77 @@
           <a:lstStyle/>
           <a:p>
             <a:r>
-              <a:t>FeverGate turns guideline knowledge into bedside action when the worker is alone and stock is unpredictable. Thank you — questions welcome.</a:t>
+              <a:t>FeverGate turns guideline knowledge into bedside action when the worker is alone and stock is unpredictable. Hand out the four-audience feedback form, then take questions.</a:t>
+            </a:r>
+          </a:p>
+        </p:txBody>
+      </p:sp>
+      <p:sp>
+        <p:nvSpPr>
+          <p:cNvPr id="4" name="Slide Number Placeholder 3"/>
+          <p:cNvSpPr>
+            <a:spLocks noGrp="1"/>
+          </p:cNvSpPr>
+          <p:nvPr>
+            <p:ph type="sldNum" idx="5" sz="quarter"/>
+          </p:nvPr>
+        </p:nvSpPr>
+        <p:spPr/>
+      </p:sp>
+    </p:spTree>
+  </p:cSld>
+  <p:clrMapOvr>
+    <a:masterClrMapping/>
+  </p:clrMapOvr>
+</p:notes>
+</file>
+
+<file path=ppt/notesSlides/notesSlide9.xml><?xml version="1.0" encoding="utf-8"?>
+<p:notes xmlns:a="http://schemas.openxmlformats.org/drawingml/2006/main" xmlns:p="http://schemas.openxmlformats.org/presentationml/2006/main" xmlns:r="http://schemas.openxmlformats.org/officeDocument/2006/relationships">
+  <p:cSld>
+    <p:spTree>
+      <p:nvGrpSpPr>
+        <p:cNvPr id="1" name=""/>
+        <p:cNvGrpSpPr/>
+        <p:nvPr/>
+      </p:nvGrpSpPr>
+      <p:grpSpPr>
+        <a:xfrm>
+          <a:off x="0" y="0"/>
+          <a:ext cx="0" cy="0"/>
+          <a:chOff x="0" y="0"/>
+          <a:chExt cx="0" cy="0"/>
+        </a:xfrm>
+      </p:grpSpPr>
+      <p:sp>
+        <p:nvSpPr>
+          <p:cNvPr id="2" name="Slide Image Placeholder 1"/>
+          <p:cNvSpPr>
+            <a:spLocks noGrp="1"/>
+          </p:cNvSpPr>
+          <p:nvPr>
+            <p:ph type="sldImg" idx="2"/>
+          </p:nvPr>
+        </p:nvSpPr>
+        <p:spPr/>
+      </p:sp>
+      <p:sp>
+        <p:nvSpPr>
+          <p:cNvPr id="3" name="Notes Placeholder 2"/>
+          <p:cNvSpPr>
+            <a:spLocks noGrp="1"/>
+          </p:cNvSpPr>
+          <p:nvPr>
+            <p:ph type="body" idx="3" sz="quarter"/>
+          </p:nvPr>
+        </p:nvSpPr>
+        <p:spPr/>
+        <p:txBody>
+          <a:bodyPr/>
+          <a:lstStyle/>
+          <a:p>
+            <a:r>
+              <a:t>Close on today's package: Groups A–D product, supervisor reporting, and the four-audience feedback form. Invite each audience to fill their section.</a:t>
             </a:r>
           </a:p>
         </p:txBody>
@@ -4106,7 +4177,7 @@
               </a:defRPr>
             </a:pPr>
             <a:r>
-              <a:t>Updated · Groups A–D · stock check-in · supervisor hub</a:t>
+              <a:t>Updated · Groups A–D · stock check-in · supervisor hub · feedback forms</a:t>
             </a:r>
           </a:p>
         </p:txBody>
@@ -4141,7 +4212,286 @@
               </a:defRPr>
             </a:pPr>
             <a:r>
-              <a:t>9 slides · ~5 minutes total</a:t>
+              <a:t>10 slides · ~5 minutes total</a:t>
+            </a:r>
+          </a:p>
+        </p:txBody>
+      </p:sp>
+    </p:spTree>
+  </p:cSld>
+  <p:clrMapOvr>
+    <a:masterClrMapping/>
+  </p:clrMapOvr>
+</p:sld>
+</file>
+
+<file path=ppt/slides/slide10.xml><?xml version="1.0" encoding="utf-8"?>
+<p:sld xmlns:a="http://schemas.openxmlformats.org/drawingml/2006/main" xmlns:p="http://schemas.openxmlformats.org/presentationml/2006/main" xmlns:r="http://schemas.openxmlformats.org/officeDocument/2006/relationships">
+  <p:cSld>
+    <p:spTree>
+      <p:nvGrpSpPr>
+        <p:cNvPr id="1" name=""/>
+        <p:cNvGrpSpPr/>
+        <p:nvPr/>
+      </p:nvGrpSpPr>
+      <p:grpSpPr/>
+      <p:sp>
+        <p:nvSpPr>
+          <p:cNvPr id="2" name="Rectangle 1"/>
+          <p:cNvSpPr/>
+          <p:nvPr/>
+        </p:nvSpPr>
+        <p:spPr>
+          <a:xfrm>
+            <a:off x="0" y="0"/>
+            <a:ext cx="9144000" cy="109728"/>
+          </a:xfrm>
+          <a:prstGeom prst="rect">
+            <a:avLst/>
+          </a:prstGeom>
+          <a:solidFill>
+            <a:srgbClr val="0D9488"/>
+          </a:solidFill>
+          <a:ln>
+            <a:noFill/>
+          </a:ln>
+        </p:spPr>
+        <p:style>
+          <a:lnRef idx="1">
+            <a:schemeClr val="accent1"/>
+          </a:lnRef>
+          <a:fillRef idx="3">
+            <a:schemeClr val="accent1"/>
+          </a:fillRef>
+          <a:effectRef idx="2">
+            <a:schemeClr val="accent1"/>
+          </a:effectRef>
+          <a:fontRef idx="minor">
+            <a:schemeClr val="lt1"/>
+          </a:fontRef>
+        </p:style>
+        <p:txBody>
+          <a:bodyPr rtlCol="0" anchor="ctr"/>
+          <a:lstStyle/>
+          <a:p>
+            <a:pPr algn="ctr"/>
+          </a:p>
+        </p:txBody>
+      </p:sp>
+      <p:sp>
+        <p:nvSpPr>
+          <p:cNvPr id="3" name="TextBox 2"/>
+          <p:cNvSpPr txBox="1"/>
+          <p:nvPr/>
+        </p:nvSpPr>
+        <p:spPr>
+          <a:xfrm>
+            <a:off x="8229600" y="320040"/>
+            <a:ext cx="731520" cy="274320"/>
+          </a:xfrm>
+          <a:prstGeom prst="rect">
+            <a:avLst/>
+          </a:prstGeom>
+          <a:noFill/>
+        </p:spPr>
+        <p:txBody>
+          <a:bodyPr wrap="none">
+            <a:spAutoFit/>
+          </a:bodyPr>
+          <a:lstStyle/>
+          <a:p>
+            <a:pPr algn="r">
+              <a:defRPr sz="1100">
+                <a:solidFill>
+                  <a:srgbClr val="64748B"/>
+                </a:solidFill>
+              </a:defRPr>
+            </a:pPr>
+            <a:r>
+              <a:t>9</a:t>
+            </a:r>
+          </a:p>
+        </p:txBody>
+      </p:sp>
+      <p:sp>
+        <p:nvSpPr>
+          <p:cNvPr id="4" name="TextBox 3"/>
+          <p:cNvSpPr txBox="1"/>
+          <p:nvPr/>
+        </p:nvSpPr>
+        <p:spPr>
+          <a:xfrm>
+            <a:off x="731520" y="502920"/>
+            <a:ext cx="7498079" cy="822960"/>
+          </a:xfrm>
+          <a:prstGeom prst="rect">
+            <a:avLst/>
+          </a:prstGeom>
+          <a:noFill/>
+        </p:spPr>
+        <p:txBody>
+          <a:bodyPr wrap="none">
+            <a:spAutoFit/>
+          </a:bodyPr>
+          <a:lstStyle/>
+          <a:p>
+            <a:pPr>
+              <a:defRPr sz="3200" b="1">
+                <a:solidFill>
+                  <a:srgbClr val="334155"/>
+                </a:solidFill>
+              </a:defRPr>
+            </a:pPr>
+            <a:r>
+              <a:t>Closing — today's status</a:t>
+            </a:r>
+          </a:p>
+        </p:txBody>
+      </p:sp>
+      <p:sp>
+        <p:nvSpPr>
+          <p:cNvPr id="5" name="TextBox 4"/>
+          <p:cNvSpPr txBox="1"/>
+          <p:nvPr/>
+        </p:nvSpPr>
+        <p:spPr>
+          <a:xfrm>
+            <a:off x="731520" y="1234440"/>
+            <a:ext cx="7498079" cy="457200"/>
+          </a:xfrm>
+          <a:prstGeom prst="rect">
+            <a:avLst/>
+          </a:prstGeom>
+          <a:noFill/>
+        </p:spPr>
+        <p:txBody>
+          <a:bodyPr wrap="none">
+            <a:spAutoFit/>
+          </a:bodyPr>
+          <a:lstStyle/>
+          <a:p>
+            <a:pPr>
+              <a:defRPr sz="1600">
+                <a:solidFill>
+                  <a:srgbClr val="0D9488"/>
+                </a:solidFill>
+              </a:defRPr>
+            </a:pPr>
+            <a:r>
+              <a:t>Ready to demo · ready to collect feedback</a:t>
+            </a:r>
+          </a:p>
+        </p:txBody>
+      </p:sp>
+      <p:sp>
+        <p:nvSpPr>
+          <p:cNvPr id="6" name="TextBox 5"/>
+          <p:cNvSpPr txBox="1"/>
+          <p:nvPr/>
+        </p:nvSpPr>
+        <p:spPr>
+          <a:xfrm>
+            <a:off x="822960" y="1920240"/>
+            <a:ext cx="7315200" cy="3840480"/>
+          </a:xfrm>
+          <a:prstGeom prst="rect">
+            <a:avLst/>
+          </a:prstGeom>
+          <a:noFill/>
+        </p:spPr>
+        <p:txBody>
+          <a:bodyPr wrap="square">
+            <a:spAutoFit/>
+          </a:bodyPr>
+          <a:lstStyle/>
+          <a:p>
+            <a:pPr>
+              <a:spcAft>
+                <a:spcPts val="800"/>
+              </a:spcAft>
+              <a:defRPr sz="1600" i="0">
+                <a:solidFill>
+                  <a:srgbClr val="334155"/>
+                </a:solidFill>
+              </a:defRPr>
+            </a:pPr>
+            <a:r>
+              <a:t>Live app: fever-treat-or-refer.vercel.app</a:t>
+            </a:r>
+          </a:p>
+          <a:p>
+            <a:pPr>
+              <a:spcAft>
+                <a:spcPts val="800"/>
+              </a:spcAft>
+              <a:defRPr sz="1600" i="0">
+                <a:solidFill>
+                  <a:srgbClr val="334155"/>
+                </a:solidFill>
+              </a:defRPr>
+            </a:pPr>
+            <a:r>
+              <a:t>Four outcomes: A immediate refer · B urgent refer · C treat &amp; monitor · D treat</a:t>
+            </a:r>
+          </a:p>
+          <a:p>
+            <a:pPr>
+              <a:spcAft>
+                <a:spcPts val="800"/>
+              </a:spcAft>
+              <a:defRPr sz="1600" i="0">
+                <a:solidFill>
+                  <a:srgbClr val="334155"/>
+                </a:solidFill>
+              </a:defRPr>
+            </a:pPr>
+            <a:r>
+              <a:t>Clinic stock check-in · URL-only supervisor hub · shared decision labels</a:t>
+            </a:r>
+          </a:p>
+          <a:p>
+            <a:pPr>
+              <a:spcAft>
+                <a:spcPts val="800"/>
+              </a:spcAft>
+              <a:defRPr sz="1600" i="0">
+                <a:solidFill>
+                  <a:srgbClr val="334155"/>
+                </a:solidFill>
+              </a:defRPr>
+            </a:pPr>
+            <a:r>
+              <a:t>Feedback form (today): Expert · Medic · Computer science · General public</a:t>
+            </a:r>
+          </a:p>
+          <a:p>
+            <a:pPr>
+              <a:spcAft>
+                <a:spcPts val="800"/>
+              </a:spcAft>
+              <a:defRPr sz="1600" i="0">
+                <a:solidFill>
+                  <a:srgbClr val="334155"/>
+                </a:solidFill>
+              </a:defRPr>
+            </a:pPr>
+            <a:r>
+              <a:t>Next ask: supervised clinical audit → limited field pilot</a:t>
+            </a:r>
+          </a:p>
+          <a:p>
+            <a:pPr>
+              <a:spcAft>
+                <a:spcPts val="800"/>
+              </a:spcAft>
+              <a:defRPr sz="1600" i="0">
+                <a:solidFill>
+                  <a:srgbClr val="334155"/>
+                </a:solidFill>
+              </a:defRPr>
+            </a:pPr>
+            <a:r>
+              <a:t>Thank you — questions welcome.</a:t>
             </a:r>
           </a:p>
         </p:txBody>
@@ -5698,6 +6048,21 @@
               <a:t>Shared decision labels across triage, reports, and dashboard</a:t>
             </a:r>
           </a:p>
+          <a:p>
+            <a:pPr>
+              <a:spcAft>
+                <a:spcPts val="800"/>
+              </a:spcAft>
+              <a:defRPr sz="1600" i="0">
+                <a:solidFill>
+                  <a:srgbClr val="334155"/>
+                </a:solidFill>
+              </a:defRPr>
+            </a:pPr>
+            <a:r>
+              <a:t>Four-audience feedback form (expert · medic · CS · public)</a:t>
+            </a:r>
+          </a:p>
         </p:txBody>
       </p:sp>
     </p:spTree>
@@ -6178,7 +6543,7 @@
               </a:defRPr>
             </a:pPr>
             <a:r>
-              <a:t>Ask: field validation partners + epidemiology feedback</a:t>
+              <a:t>Ask: field validation partners + structured feedback after demo</a:t>
             </a:r>
           </a:p>
           <a:p>

</xml_diff>